<commit_message>
Name the USP explicitly - judges grade it as a criterion
Prof. Raghu's email lists 'unique selling point' as one of four graded criteria,
and the word appeared nowhere in either deck. The content was there; the label
was not, and a judge scanning a slide for it would not have found it.

TEAM_NOTES section 4 gains a USP block with three lengths: the one-liner, the
15-second version, and the technical framing for a panel that goes deeper. The
one-liner is paired with the four-second demo that proves it - drag the
confidence gate and watch the image go grey.

Submission deck: the confidence bullet now leads with 'USP', and the two
'Innovation' bullets become 'Unique 1/2'. Our own deck: 'Our answer' becomes
'Our USP' and gains the refusal half, which was missing.

Verified by exporting slide 2 of both decks through PowerPoint; no overflow in
either. Submission PDF regenerated. 40 passed, 3 skipped.

Co-Authored-By: Claude Opus 5 <noreply@anthropic.com>
</commit_message>
<xml_diff>
--- a/SIH2026-DeltaForce-SIH1733-IDEA-SUBMISSION.pptx
+++ b/SIH2026-DeltaForce-SIH1733-IDEA-SUBMISSION.pptx
@@ -5962,7 +5962,7 @@
             </a:pPr>
             <a:r>
               <a:rPr sz="1800" b="0"/>
-              <a:t>•  Radar carries no colour — so every pixel also ships a CALIBRATED CONFIDENCE. Below your threshold the output goes grey: “insufficient evidence”, not a confident guess.</a:t>
+              <a:t>•  USP — radar carries no colour, so every pixel ships a CALIBRATED CONFIDENCE. Below your threshold the output goes grey: “insufficient evidence”, not a confident guess.</a:t>
             </a:r>
           </a:p>
           <a:p>
@@ -5986,7 +5986,7 @@
             </a:pPr>
             <a:r>
               <a:rPr sz="1800" b="0"/>
-              <a:t>•  Innovation 1 — we diagnosed why existing models look unsatisfactory. L1 loss is minimised by the conditional MEAN of every plausible colour, which is blur by definition, and PSNR rewards the same thing so standard evaluation cannot see it. A gradient-difference loss fixed it: sharpness 0.21 → 0.78 of the real optical, saturation 45% → 102%.</a:t>
+              <a:t>•  Unique 1 — we diagnosed WHY existing models look unsatisfactory. L1 loss is minimised by the conditional MEAN of every plausible colour, which is blur by definition, and PSNR rewards the same thing so standard evaluation cannot see it. A gradient-difference loss fixed it: sharpness 0.21 → 0.78 of the real optical, saturation 45% → 102%.</a:t>
             </a:r>
           </a:p>
           <a:p>
@@ -5998,7 +5998,7 @@
             </a:pPr>
             <a:r>
               <a:rPr sz="1800" b="0"/>
-              <a:t>•  Innovation 2 — we measure what does not work and refuse to ship it. Built-up land cover from radar alone scores AUC 0.483, below chance, so the app reports it as unavailable and says why.</a:t>
+              <a:t>•  Unique 2 — we measure what does not work and REFUSE to ship it. Built-up land cover from radar alone scores AUC 0.483, below chance, so the app reports it as unavailable and says why.</a:t>
             </a:r>
           </a:p>
         </p:txBody>

</xml_diff>

<commit_message>
Drop the Team ID placeholder from the title slide
Removed at the team's request - there is no Team ID for the internal hackathon,
and a slide reading '<FILL BEFORE UPLOAD>' in front of a judge is worse than the
field simply being absent. Everything else on the title page is unchanged.

If this deck is later uploaded to the SIH portal, Team ID is part of the official
title-page block and should go back in.

Co-Authored-By: Claude Opus 5 <noreply@anthropic.com>
</commit_message>
<xml_diff>
--- a/SIH2026-DeltaForce-SIH1733-IDEA-SUBMISSION.pptx
+++ b/SIH2026-DeltaForce-SIH1733-IDEA-SUBMISSION.pptx
@@ -5703,18 +5703,6 @@
             </a:pPr>
             <a:r>
               <a:rPr sz="1400" b="0"/>
-              <a:t>Team ID – &lt;FILL BEFORE UPLOAD&gt;</a:t>
-            </a:r>
-          </a:p>
-          <a:p>
-            <a:pPr marL="0" indent="0">
-              <a:spcAft>
-                <a:spcPts val="600"/>
-              </a:spcAft>
-              <a:buNone/>
-            </a:pPr>
-            <a:r>
-              <a:rPr sz="1400" b="0"/>
               <a:t>Team Name – Delta Force</a:t>
             </a:r>
           </a:p>

</xml_diff>

<commit_message>
Team number 71 on both decks and in the notes
Kept distinct from Team ID: 71 is the internal hackathon team number; the SIH
portal Team ID does not exist until registration and stays unfilled rather than
being guessed at.

Co-Authored-By: Claude Opus 5 <noreply@anthropic.com>
</commit_message>
<xml_diff>
--- a/SIH2026-DeltaForce-SIH1733-IDEA-SUBMISSION.pptx
+++ b/SIH2026-DeltaForce-SIH1733-IDEA-SUBMISSION.pptx
@@ -5703,6 +5703,18 @@
             </a:pPr>
             <a:r>
               <a:rPr sz="1400" b="0"/>
+              <a:t>Team Number – 71</a:t>
+            </a:r>
+          </a:p>
+          <a:p>
+            <a:pPr marL="0" indent="0">
+              <a:spcAft>
+                <a:spcPts val="600"/>
+              </a:spcAft>
+              <a:buNone/>
+            </a:pPr>
+            <a:r>
+              <a:rPr sz="1400" b="0"/>
               <a:t>Team Name – Delta Force</a:t>
             </a:r>
           </a:p>

</xml_diff>